<commit_message>
update ANOVA test slide
</commit_message>
<xml_diff>
--- a/reports/final/The-Perception-Gap-JuliaMC3.0.pptx
+++ b/reports/final/The-Perception-Gap-JuliaMC3.0.pptx
@@ -24288,7 +24288,7 @@
           <a:p>
             <a:r>
               <a:rPr lang="en-US" sz="1400" i="1" dirty="0" err="1"/>
-              <a:t>no_report_rate</a:t>
+              <a:t>total_gap_rate</a:t>
             </a:r>
             <a:r>
               <a:rPr lang="en-US" sz="1400" i="1" dirty="0"/>
@@ -31583,22 +31583,6 @@
                 </a:solidFill>
               </a:rPr>
               <a:t>                - officer -&gt; system </a:t>
-            </a:r>
-          </a:p>
-          <a:p>
-            <a:pPr>
-              <a:buFontTx/>
-              <a:buChar char="-"/>
-            </a:pPr>
-            <a:r>
-              <a:rPr lang="en-US" sz="1400" dirty="0">
-                <a:solidFill>
-                  <a:schemeClr val="tx1">
-                    <a:lumMod val="50000"/>
-                  </a:schemeClr>
-                </a:solidFill>
-              </a:rPr>
-              <a:t>Use Mixed models </a:t>
             </a:r>
           </a:p>
           <a:p>

</xml_diff>

<commit_message>
Update incident classification slide
</commit_message>
<xml_diff>
--- a/reports/final/The-Perception-Gap-JuliaMC3.0.pptx
+++ b/reports/final/The-Perception-Gap-JuliaMC3.0.pptx
@@ -39788,13 +39788,12 @@
                   <a:buNone/>
                 </a:pPr>
                 <a:r>
-                  <a:rPr lang="en-US" sz="1600" b="1" dirty="0">
+                  <a:rPr lang="en-US" sz="1200" b="1" dirty="0">
                     <a:latin typeface="Andale Mono" panose="020B0509000000000004" pitchFamily="49" charset="0"/>
                     <a:ea typeface="Lato" panose="020F0502020204030203" pitchFamily="34" charset="0"/>
                     <a:cs typeface="Lato" panose="020F0502020204030203" pitchFamily="34" charset="0"/>
-                    <a:sym typeface="Inter"/>
                   </a:rPr>
-                  <a:t>High </a:t>
+                  <a:t>Violent/</a:t>
                 </a:r>
               </a:p>
               <a:p>
@@ -39808,14 +39807,14 @@
                   <a:buNone/>
                 </a:pPr>
                 <a:r>
-                  <a:rPr lang="en-US" sz="1200" dirty="0">
+                  <a:rPr lang="en-US" sz="1200" b="1" dirty="0">
                     <a:latin typeface="Andale Mono" panose="020B0509000000000004" pitchFamily="49" charset="0"/>
                     <a:ea typeface="Lato" panose="020F0502020204030203" pitchFamily="34" charset="0"/>
                     <a:cs typeface="Lato" panose="020F0502020204030203" pitchFamily="34" charset="0"/>
                   </a:rPr>
-                  <a:t>Violent/serious crimes</a:t>
+                  <a:t>emergency</a:t>
                 </a:r>
-                <a:endParaRPr sz="1200" dirty="0">
+                <a:endParaRPr sz="1200" b="1" dirty="0">
                   <a:latin typeface="Andale Mono" panose="020B0509000000000004" pitchFamily="49" charset="0"/>
                   <a:ea typeface="Lato" panose="020F0502020204030203" pitchFamily="34" charset="0"/>
                   <a:cs typeface="Lato" panose="020F0502020204030203" pitchFamily="34" charset="0"/>
@@ -39947,10 +39946,10 @@
           </p:nvGrpSpPr>
           <p:grpSpPr>
             <a:xfrm>
-              <a:off x="1066149" y="3931943"/>
-              <a:ext cx="465342" cy="635774"/>
-              <a:chOff x="1082148" y="3943904"/>
-              <a:chExt cx="486453" cy="664689"/>
+              <a:off x="1066149" y="3931941"/>
+              <a:ext cx="465342" cy="635777"/>
+              <a:chOff x="1082148" y="3943901"/>
+              <a:chExt cx="486453" cy="664692"/>
             </a:xfrm>
           </p:grpSpPr>
           <p:sp>
@@ -39967,12 +39966,12 @@
             </p:nvSpPr>
             <p:spPr>
               <a:xfrm>
-                <a:off x="1082148" y="3943904"/>
+                <a:off x="1082148" y="3943901"/>
                 <a:ext cx="486453" cy="419523"/>
               </a:xfrm>
               <a:prstGeom prst="hexagon">
                 <a:avLst>
-                  <a:gd name="adj" fmla="val 30376"/>
+                  <a:gd name="adj" fmla="val 26580"/>
                   <a:gd name="vf" fmla="val 115470"/>
                 </a:avLst>
               </a:prstGeom>
@@ -40007,30 +40006,33 @@
                   </a:spcAft>
                   <a:buNone/>
                 </a:pPr>
+                <a:endParaRPr lang="en-US" b="1" dirty="0">
+                  <a:latin typeface="Andale Mono" panose="020B0509000000000004" pitchFamily="49" charset="0"/>
+                  <a:ea typeface="Inter"/>
+                  <a:cs typeface="Inter"/>
+                  <a:sym typeface="Inter"/>
+                </a:endParaRPr>
+              </a:p>
+              <a:p>
+                <a:pPr algn="ctr"/>
                 <a:r>
-                  <a:rPr lang="en-US" b="1" dirty="0">
+                  <a:rPr lang="en-US" sz="1200" b="1" dirty="0">
+                    <a:latin typeface="Andale Mono" panose="020B0509000000000004" pitchFamily="49" charset="0"/>
+                  </a:rPr>
+                  <a:t>Serious criminal/</a:t>
+                </a:r>
+              </a:p>
+              <a:p>
+                <a:pPr algn="ctr"/>
+                <a:r>
+                  <a:rPr lang="en-US" sz="1200" b="1" dirty="0">
                     <a:latin typeface="Andale Mono" panose="020B0509000000000004" pitchFamily="49" charset="0"/>
                     <a:ea typeface="Inter"/>
                     <a:cs typeface="Inter"/>
                     <a:sym typeface="Inter"/>
                   </a:rPr>
-                  <a:t>Medium</a:t>
+                  <a:t>Property related crimes</a:t>
                 </a:r>
-              </a:p>
-              <a:p>
-                <a:pPr algn="ctr"/>
-                <a:r>
-                  <a:rPr lang="en-US" sz="1200" dirty="0">
-                    <a:latin typeface="Andale Mono" panose="020B0509000000000004" pitchFamily="49" charset="0"/>
-                  </a:rPr>
-                  <a:t>Property or financial related crimes</a:t>
-                </a:r>
-                <a:endParaRPr lang="en-US" sz="1200" dirty="0">
-                  <a:latin typeface="Andale Mono" panose="020B0509000000000004" pitchFamily="49" charset="0"/>
-                  <a:ea typeface="Inter"/>
-                  <a:cs typeface="Inter"/>
-                  <a:sym typeface="Inter"/>
-                </a:endParaRPr>
               </a:p>
               <a:p>
                 <a:pPr marL="0" lvl="0" indent="0" algn="ctr" rtl="0">
@@ -40235,29 +40237,12 @@
                   <a:buNone/>
                 </a:pPr>
                 <a:r>
-                  <a:rPr lang="en-US" b="1" dirty="0">
+                  <a:rPr lang="en-US" sz="1200" b="1" dirty="0">
                     <a:latin typeface="Andale Mono" panose="020B0509000000000004" pitchFamily="49" charset="0"/>
                   </a:rPr>
-                  <a:t>Low</a:t>
+                  <a:t>Lower-Level/ Society-Related Offenses</a:t>
                 </a:r>
-              </a:p>
-              <a:p>
-                <a:pPr marL="0" lvl="0" indent="0" algn="ctr" rtl="0">
-                  <a:spcBef>
-                    <a:spcPts val="0"/>
-                  </a:spcBef>
-                  <a:spcAft>
-                    <a:spcPts val="0"/>
-                  </a:spcAft>
-                  <a:buNone/>
-                </a:pPr>
-                <a:r>
-                  <a:rPr lang="en-US" sz="1200" dirty="0">
-                    <a:latin typeface="Andale Mono" panose="020B0509000000000004" pitchFamily="49" charset="0"/>
-                  </a:rPr>
-                  <a:t>Minor non-violent criminal incidents</a:t>
-                </a:r>
-                <a:endParaRPr sz="1200" dirty="0">
+                <a:endParaRPr sz="1200" b="1" dirty="0">
                   <a:latin typeface="Andale Mono" panose="020B0509000000000004" pitchFamily="49" charset="0"/>
                   <a:ea typeface="Inter"/>
                   <a:cs typeface="Inter"/>
@@ -40432,17 +40417,11 @@
               <a:buNone/>
             </a:pPr>
             <a:r>
-              <a:rPr lang="en-US" sz="1200" dirty="0">
+              <a:rPr lang="en-US" sz="1200" b="1" dirty="0">
                 <a:latin typeface="Andale Mono" panose="020B0509000000000004" pitchFamily="49" charset="0"/>
               </a:rPr>
-              <a:t>Non-Criminal/ Service Related</a:t>
+              <a:t>Service  Administrative  Non-Criminal</a:t>
             </a:r>
-            <a:endParaRPr sz="1200" dirty="0">
-              <a:latin typeface="Andale Mono" panose="020B0509000000000004" pitchFamily="49" charset="0"/>
-              <a:ea typeface="Inter"/>
-              <a:cs typeface="Inter"/>
-              <a:sym typeface="Inter"/>
-            </a:endParaRPr>
           </a:p>
         </p:txBody>
       </p:sp>

</xml_diff>